<commit_message>
Take the WhatsApp look everywhere + add iPhone 15 prototype
- New prototype/ — a self-contained, zero-dependency iPhone 15 prototype
  (Launch, Today, People, Balance) with WhatsApp app-bar, chat-bubble
  nudges, contact-list scores, Dynamic Island, status bar and tab bar
- Reskin the slide deck to the WhatsApp light/green theme (green title +
  closing slides, light content slides, white cards, green accents)
- Regenerate comit.pptx to match (green title/closing, light content)
- Reskin the README hero banner to WhatsApp green
- Add docs/images/mobile.svg and a "On your phone" README section
</commit_message>
<xml_diff>
--- a/presentation/comit.pptx
+++ b/presentation/comit.pptx
@@ -1658,7 +1658,7 @@
     <p:bg>
       <p:bgPr>
         <a:solidFill>
-          <a:srgbClr val="0D0D12"/>
+          <a:srgbClr val="075E54"/>
         </a:solidFill>
       </p:bgPr>
     </p:bg>
@@ -1703,7 +1703,7 @@
             <a:r>
               <a:rPr lang="en-US" sz="1300" spc="300" kern="0" dirty="0">
                 <a:solidFill>
-                  <a:srgbClr val="45D0D0"/>
+                  <a:srgbClr val="D9F3EC"/>
                 </a:solidFill>
                 <a:latin typeface="Calibri" pitchFamily="34" charset="0"/>
                 <a:ea typeface="Calibri" pitchFamily="34" charset="-122"/>
@@ -1724,7 +1724,7 @@
         <p:spPr>
           <a:xfrm>
             <a:off x="566928" y="1783080"/>
-            <a:ext cx="7315200" cy="1755648"/>
+            <a:ext cx="8229600" cy="1755648"/>
           </a:xfrm>
           <a:prstGeom prst="rect">
             <a:avLst/>
@@ -1742,27 +1742,13 @@
             <a:r>
               <a:rPr lang="en-US" sz="9600" b="1" spc="-100" kern="0" dirty="0">
                 <a:solidFill>
-                  <a:srgbClr val="B14DFF"/>
-                </a:solidFill>
-                <a:latin typeface="Calibri" pitchFamily="34" charset="0"/>
-                <a:ea typeface="Calibri" pitchFamily="34" charset="-122"/>
-                <a:cs typeface="Calibri" pitchFamily="34" charset="-120"/>
-              </a:rPr>
-              <a:t>com</a:t>
-            </a:r>
-            <a:pPr indent="0" marL="0">
-              <a:buNone/>
-            </a:pPr>
-            <a:r>
-              <a:rPr lang="en-US" sz="9600" b="1" spc="-100" kern="0" dirty="0">
-                <a:solidFill>
-                  <a:srgbClr val="45D0D0"/>
-                </a:solidFill>
-                <a:latin typeface="Calibri" pitchFamily="34" charset="0"/>
-                <a:ea typeface="Calibri" pitchFamily="34" charset="-122"/>
-                <a:cs typeface="Calibri" pitchFamily="34" charset="-120"/>
-              </a:rPr>
-              <a:t>it</a:t>
+                  <a:srgbClr val="FFFFFF"/>
+                </a:solidFill>
+                <a:latin typeface="Calibri" pitchFamily="34" charset="0"/>
+                <a:ea typeface="Calibri" pitchFamily="34" charset="-122"/>
+                <a:cs typeface="Calibri" pitchFamily="34" charset="-120"/>
+              </a:rPr>
+              <a:t>comit</a:t>
             </a:r>
             <a:endParaRPr lang="en-US" sz="9600" dirty="0"/>
           </a:p>
@@ -1795,7 +1781,7 @@
             <a:r>
               <a:rPr lang="en-US" sz="3000" dirty="0">
                 <a:solidFill>
-                  <a:srgbClr val="ECECF4"/>
+                  <a:srgbClr val="FFFFFF"/>
                 </a:solidFill>
                 <a:latin typeface="Calibri" pitchFamily="34" charset="0"/>
                 <a:ea typeface="Calibri" pitchFamily="34" charset="-122"/>
@@ -1816,7 +1802,7 @@
         <p:spPr>
           <a:xfrm>
             <a:off x="640080" y="3977640"/>
-            <a:ext cx="7315200" cy="822960"/>
+            <a:ext cx="7680960" cy="822960"/>
           </a:xfrm>
           <a:prstGeom prst="rect">
             <a:avLst/>
@@ -1834,7 +1820,7 @@
             <a:r>
               <a:rPr lang="en-US" sz="1600" dirty="0">
                 <a:solidFill>
-                  <a:srgbClr val="9A9AB4"/>
+                  <a:srgbClr val="D9F3EC"/>
                 </a:solidFill>
                 <a:latin typeface="Calibri" pitchFamily="34" charset="0"/>
                 <a:ea typeface="Calibri" pitchFamily="34" charset="-122"/>
@@ -1860,12 +1846,9 @@
           <a:prstGeom prst="ellipse">
             <a:avLst/>
           </a:prstGeom>
-          <a:solidFill>
-            <a:srgbClr val="0D0D12"/>
-          </a:solidFill>
           <a:ln w="50800">
             <a:solidFill>
-              <a:srgbClr val="46D398"/>
+              <a:srgbClr val="3E8E81"/>
             </a:solidFill>
             <a:prstDash val="solid"/>
           </a:ln>
@@ -1873,7 +1856,7 @@
       </p:sp>
       <p:sp>
         <p:nvSpPr>
-          <p:cNvPr id="7" name="Text 5"/>
+          <p:cNvPr id="7" name="Shape 5"/>
           <p:cNvSpPr/>
           <p:nvPr/>
         </p:nvSpPr>
@@ -1882,54 +1865,12 @@
             <a:off x="8686800" y="1737360"/>
             <a:ext cx="1005840" cy="1005840"/>
           </a:xfrm>
-          <a:prstGeom prst="rect">
-            <a:avLst/>
-          </a:prstGeom>
-          <a:noFill/>
-          <a:ln/>
-        </p:spPr>
-        <p:txBody>
-          <a:bodyPr wrap="square" rtlCol="0" anchor="ctr"/>
-          <a:lstStyle/>
-          <a:p>
-            <a:pPr algn="ctr" indent="0" marL="0">
-              <a:buNone/>
-            </a:pPr>
-            <a:r>
-              <a:rPr lang="en-US" sz="1400" b="1" dirty="0">
-                <a:solidFill>
-                  <a:srgbClr val="ECECF4"/>
-                </a:solidFill>
-                <a:latin typeface="Calibri" pitchFamily="34" charset="0"/>
-                <a:ea typeface="Calibri" pitchFamily="34" charset="-122"/>
-                <a:cs typeface="Calibri" pitchFamily="34" charset="-120"/>
-              </a:rPr>
-              <a:t>84</a:t>
-            </a:r>
-            <a:endParaRPr lang="en-US" sz="1400" dirty="0"/>
-          </a:p>
-        </p:txBody>
-      </p:sp>
-      <p:sp>
-        <p:nvSpPr>
-          <p:cNvPr id="8" name="Shape 6"/>
-          <p:cNvSpPr/>
-          <p:nvPr/>
-        </p:nvSpPr>
-        <p:spPr>
-          <a:xfrm>
-            <a:off x="9921240" y="2286000"/>
-            <a:ext cx="822960" cy="822960"/>
-          </a:xfrm>
           <a:prstGeom prst="ellipse">
             <a:avLst/>
           </a:prstGeom>
-          <a:solidFill>
-            <a:srgbClr val="0D0D12"/>
-          </a:solidFill>
           <a:ln w="50800">
             <a:solidFill>
-              <a:srgbClr val="45D0D0"/>
+              <a:srgbClr val="FFFFFF"/>
             </a:solidFill>
             <a:prstDash val="solid"/>
           </a:ln>
@@ -1937,7 +1878,46 @@
       </p:sp>
       <p:sp>
         <p:nvSpPr>
-          <p:cNvPr id="9" name="Text 7"/>
+          <p:cNvPr id="8" name="Text 6"/>
+          <p:cNvSpPr/>
+          <p:nvPr/>
+        </p:nvSpPr>
+        <p:spPr>
+          <a:xfrm>
+            <a:off x="8686800" y="1737360"/>
+            <a:ext cx="1005840" cy="1005840"/>
+          </a:xfrm>
+          <a:prstGeom prst="rect">
+            <a:avLst/>
+          </a:prstGeom>
+          <a:noFill/>
+          <a:ln/>
+        </p:spPr>
+        <p:txBody>
+          <a:bodyPr wrap="square" rtlCol="0" anchor="ctr"/>
+          <a:lstStyle/>
+          <a:p>
+            <a:pPr algn="ctr" indent="0" marL="0">
+              <a:buNone/>
+            </a:pPr>
+            <a:r>
+              <a:rPr lang="en-US" sz="1400" b="1" dirty="0">
+                <a:solidFill>
+                  <a:srgbClr val="FFFFFF"/>
+                </a:solidFill>
+                <a:latin typeface="Calibri" pitchFamily="34" charset="0"/>
+                <a:ea typeface="Calibri" pitchFamily="34" charset="-122"/>
+                <a:cs typeface="Calibri" pitchFamily="34" charset="-120"/>
+              </a:rPr>
+              <a:t>84</a:t>
+            </a:r>
+            <a:endParaRPr lang="en-US" sz="1400" dirty="0"/>
+          </a:p>
+        </p:txBody>
+      </p:sp>
+      <p:sp>
+        <p:nvSpPr>
+          <p:cNvPr id="9" name="Shape 7"/>
           <p:cNvSpPr/>
           <p:nvPr/>
         </p:nvSpPr>
@@ -1946,54 +1926,12 @@
             <a:off x="9921240" y="2286000"/>
             <a:ext cx="822960" cy="822960"/>
           </a:xfrm>
-          <a:prstGeom prst="rect">
-            <a:avLst/>
-          </a:prstGeom>
-          <a:noFill/>
-          <a:ln/>
-        </p:spPr>
-        <p:txBody>
-          <a:bodyPr wrap="square" rtlCol="0" anchor="ctr"/>
-          <a:lstStyle/>
-          <a:p>
-            <a:pPr algn="ctr" indent="0" marL="0">
-              <a:buNone/>
-            </a:pPr>
-            <a:r>
-              <a:rPr lang="en-US" sz="1400" b="1" dirty="0">
-                <a:solidFill>
-                  <a:srgbClr val="ECECF4"/>
-                </a:solidFill>
-                <a:latin typeface="Calibri" pitchFamily="34" charset="0"/>
-                <a:ea typeface="Calibri" pitchFamily="34" charset="-122"/>
-                <a:cs typeface="Calibri" pitchFamily="34" charset="-120"/>
-              </a:rPr>
-              <a:t>70</a:t>
-            </a:r>
-            <a:endParaRPr lang="en-US" sz="1400" dirty="0"/>
-          </a:p>
-        </p:txBody>
-      </p:sp>
-      <p:sp>
-        <p:nvSpPr>
-          <p:cNvPr id="10" name="Shape 8"/>
-          <p:cNvSpPr/>
-          <p:nvPr/>
-        </p:nvSpPr>
-        <p:spPr>
-          <a:xfrm>
-            <a:off x="9601200" y="3383280"/>
-            <a:ext cx="731520" cy="731520"/>
-          </a:xfrm>
           <a:prstGeom prst="ellipse">
             <a:avLst/>
           </a:prstGeom>
-          <a:solidFill>
-            <a:srgbClr val="0D0D12"/>
-          </a:solidFill>
           <a:ln w="50800">
             <a:solidFill>
-              <a:srgbClr val="FFB454"/>
+              <a:srgbClr val="3E8E81"/>
             </a:solidFill>
             <a:prstDash val="solid"/>
           </a:ln>
@@ -2001,7 +1939,68 @@
       </p:sp>
       <p:sp>
         <p:nvSpPr>
+          <p:cNvPr id="10" name="Shape 8"/>
+          <p:cNvSpPr/>
+          <p:nvPr/>
+        </p:nvSpPr>
+        <p:spPr>
+          <a:xfrm>
+            <a:off x="9921240" y="2286000"/>
+            <a:ext cx="822960" cy="822960"/>
+          </a:xfrm>
+          <a:prstGeom prst="ellipse">
+            <a:avLst/>
+          </a:prstGeom>
+          <a:ln w="50800">
+            <a:solidFill>
+              <a:srgbClr val="D9FDD3"/>
+            </a:solidFill>
+            <a:prstDash val="solid"/>
+          </a:ln>
+        </p:spPr>
+      </p:sp>
+      <p:sp>
+        <p:nvSpPr>
           <p:cNvPr id="11" name="Text 9"/>
+          <p:cNvSpPr/>
+          <p:nvPr/>
+        </p:nvSpPr>
+        <p:spPr>
+          <a:xfrm>
+            <a:off x="9921240" y="2286000"/>
+            <a:ext cx="822960" cy="822960"/>
+          </a:xfrm>
+          <a:prstGeom prst="rect">
+            <a:avLst/>
+          </a:prstGeom>
+          <a:noFill/>
+          <a:ln/>
+        </p:spPr>
+        <p:txBody>
+          <a:bodyPr wrap="square" rtlCol="0" anchor="ctr"/>
+          <a:lstStyle/>
+          <a:p>
+            <a:pPr algn="ctr" indent="0" marL="0">
+              <a:buNone/>
+            </a:pPr>
+            <a:r>
+              <a:rPr lang="en-US" sz="1400" b="1" dirty="0">
+                <a:solidFill>
+                  <a:srgbClr val="FFFFFF"/>
+                </a:solidFill>
+                <a:latin typeface="Calibri" pitchFamily="34" charset="0"/>
+                <a:ea typeface="Calibri" pitchFamily="34" charset="-122"/>
+                <a:cs typeface="Calibri" pitchFamily="34" charset="-120"/>
+              </a:rPr>
+              <a:t>70</a:t>
+            </a:r>
+            <a:endParaRPr lang="en-US" sz="1400" dirty="0"/>
+          </a:p>
+        </p:txBody>
+      </p:sp>
+      <p:sp>
+        <p:nvSpPr>
+          <p:cNvPr id="12" name="Shape 10"/>
           <p:cNvSpPr/>
           <p:nvPr/>
         </p:nvSpPr>
@@ -2010,6 +2009,50 @@
             <a:off x="9601200" y="3383280"/>
             <a:ext cx="731520" cy="731520"/>
           </a:xfrm>
+          <a:prstGeom prst="ellipse">
+            <a:avLst/>
+          </a:prstGeom>
+          <a:ln w="50800">
+            <a:solidFill>
+              <a:srgbClr val="3E8E81"/>
+            </a:solidFill>
+            <a:prstDash val="solid"/>
+          </a:ln>
+        </p:spPr>
+      </p:sp>
+      <p:sp>
+        <p:nvSpPr>
+          <p:cNvPr id="13" name="Shape 11"/>
+          <p:cNvSpPr/>
+          <p:nvPr/>
+        </p:nvSpPr>
+        <p:spPr>
+          <a:xfrm>
+            <a:off x="9601200" y="3383280"/>
+            <a:ext cx="731520" cy="731520"/>
+          </a:xfrm>
+          <a:prstGeom prst="ellipse">
+            <a:avLst/>
+          </a:prstGeom>
+          <a:ln w="50800">
+            <a:solidFill>
+              <a:srgbClr val="BDEAD3"/>
+            </a:solidFill>
+            <a:prstDash val="solid"/>
+          </a:ln>
+        </p:spPr>
+      </p:sp>
+      <p:sp>
+        <p:nvSpPr>
+          <p:cNvPr id="14" name="Text 12"/>
+          <p:cNvSpPr/>
+          <p:nvPr/>
+        </p:nvSpPr>
+        <p:spPr>
+          <a:xfrm>
+            <a:off x="9601200" y="3383280"/>
+            <a:ext cx="731520" cy="731520"/>
+          </a:xfrm>
           <a:prstGeom prst="rect">
             <a:avLst/>
           </a:prstGeom>
@@ -2026,7 +2069,7 @@
             <a:r>
               <a:rPr lang="en-US" sz="1400" b="1" dirty="0">
                 <a:solidFill>
-                  <a:srgbClr val="ECECF4"/>
+                  <a:srgbClr val="FFFFFF"/>
                 </a:solidFill>
                 <a:latin typeface="Calibri" pitchFamily="34" charset="0"/>
                 <a:ea typeface="Calibri" pitchFamily="34" charset="-122"/>
@@ -2040,7 +2083,7 @@
       </p:sp>
       <p:sp>
         <p:nvSpPr>
-          <p:cNvPr id="12" name="Text 10"/>
+          <p:cNvPr id="15" name="Text 13"/>
           <p:cNvSpPr/>
           <p:nvPr/>
         </p:nvSpPr>
@@ -2065,7 +2108,7 @@
             <a:r>
               <a:rPr lang="en-US" sz="1400" dirty="0">
                 <a:solidFill>
-                  <a:srgbClr val="6B6B85"/>
+                  <a:srgbClr val="D9F3EC"/>
                 </a:solidFill>
                 <a:latin typeface="Calibri" pitchFamily="34" charset="0"/>
                 <a:ea typeface="Calibri" pitchFamily="34" charset="-122"/>
@@ -2091,7 +2134,7 @@
     <p:bg>
       <p:bgPr>
         <a:solidFill>
-          <a:srgbClr val="0D0D12"/>
+          <a:srgbClr val="075E54"/>
         </a:solidFill>
       </p:bgPr>
     </p:bg>
@@ -2118,7 +2161,7 @@
         <p:spPr>
           <a:xfrm>
             <a:off x="566928" y="2011680"/>
-            <a:ext cx="7315200" cy="1755648"/>
+            <a:ext cx="8229600" cy="1755648"/>
           </a:xfrm>
           <a:prstGeom prst="rect">
             <a:avLst/>
@@ -2136,27 +2179,13 @@
             <a:r>
               <a:rPr lang="en-US" sz="9600" b="1" spc="-100" kern="0" dirty="0">
                 <a:solidFill>
-                  <a:srgbClr val="B14DFF"/>
-                </a:solidFill>
-                <a:latin typeface="Calibri" pitchFamily="34" charset="0"/>
-                <a:ea typeface="Calibri" pitchFamily="34" charset="-122"/>
-                <a:cs typeface="Calibri" pitchFamily="34" charset="-120"/>
-              </a:rPr>
-              <a:t>com</a:t>
-            </a:r>
-            <a:pPr indent="0" marL="0">
-              <a:buNone/>
-            </a:pPr>
-            <a:r>
-              <a:rPr lang="en-US" sz="9600" b="1" spc="-100" kern="0" dirty="0">
-                <a:solidFill>
-                  <a:srgbClr val="45D0D0"/>
-                </a:solidFill>
-                <a:latin typeface="Calibri" pitchFamily="34" charset="0"/>
-                <a:ea typeface="Calibri" pitchFamily="34" charset="-122"/>
-                <a:cs typeface="Calibri" pitchFamily="34" charset="-120"/>
-              </a:rPr>
-              <a:t>it</a:t>
+                  <a:srgbClr val="FFFFFF"/>
+                </a:solidFill>
+                <a:latin typeface="Calibri" pitchFamily="34" charset="0"/>
+                <a:ea typeface="Calibri" pitchFamily="34" charset="-122"/>
+                <a:cs typeface="Calibri" pitchFamily="34" charset="-120"/>
+              </a:rPr>
+              <a:t>comit</a:t>
             </a:r>
             <a:endParaRPr lang="en-US" sz="9600" dirty="0"/>
           </a:p>
@@ -2189,7 +2218,7 @@
             <a:r>
               <a:rPr lang="en-US" sz="2800" dirty="0">
                 <a:solidFill>
-                  <a:srgbClr val="ECECF4"/>
+                  <a:srgbClr val="FFFFFF"/>
                 </a:solidFill>
                 <a:latin typeface="Calibri" pitchFamily="34" charset="0"/>
                 <a:ea typeface="Calibri" pitchFamily="34" charset="-122"/>
@@ -2228,7 +2257,7 @@
             <a:r>
               <a:rPr lang="en-US" sz="1800" dirty="0">
                 <a:solidFill>
-                  <a:srgbClr val="45D0D0"/>
+                  <a:srgbClr val="9FE9D2"/>
                 </a:solidFill>
                 <a:latin typeface="Calibri" pitchFamily="34" charset="0"/>
                 <a:ea typeface="Calibri" pitchFamily="34" charset="-122"/>
@@ -2267,7 +2296,7 @@
             <a:r>
               <a:rPr lang="en-US" sz="1500" dirty="0">
                 <a:solidFill>
-                  <a:srgbClr val="6B6B85"/>
+                  <a:srgbClr val="D9F3EC"/>
                 </a:solidFill>
                 <a:latin typeface="Calibri" pitchFamily="34" charset="0"/>
                 <a:ea typeface="Calibri" pitchFamily="34" charset="-122"/>
@@ -2293,7 +2322,7 @@
     <p:bg>
       <p:bgPr>
         <a:solidFill>
-          <a:srgbClr val="0D0D12"/>
+          <a:srgbClr val="EEF1EC"/>
         </a:solidFill>
       </p:bgPr>
     </p:bg>
@@ -2338,7 +2367,7 @@
             <a:r>
               <a:rPr lang="en-US" sz="3800" b="1" spc="-50" kern="0" dirty="0">
                 <a:solidFill>
-                  <a:srgbClr val="ECECF4"/>
+                  <a:srgbClr val="111B21"/>
                 </a:solidFill>
                 <a:latin typeface="Calibri" pitchFamily="34" charset="0"/>
                 <a:ea typeface="Calibri" pitchFamily="34" charset="-122"/>
@@ -2380,7 +2409,7 @@
             <a:r>
               <a:rPr lang="en-US" sz="3000" b="1" dirty="0">
                 <a:solidFill>
-                  <a:srgbClr val="ECECF4"/>
+                  <a:srgbClr val="111B21"/>
                 </a:solidFill>
                 <a:latin typeface="Calibri" pitchFamily="34" charset="0"/>
                 <a:ea typeface="Calibri" pitchFamily="34" charset="-122"/>
@@ -2397,7 +2426,7 @@
             <a:r>
               <a:rPr lang="en-US" sz="3000" b="1" dirty="0">
                 <a:solidFill>
-                  <a:srgbClr val="6B6B85"/>
+                  <a:srgbClr val="8696A0"/>
                 </a:solidFill>
                 <a:latin typeface="Calibri" pitchFamily="34" charset="0"/>
                 <a:ea typeface="Calibri" pitchFamily="34" charset="-122"/>
@@ -2414,7 +2443,7 @@
             <a:r>
               <a:rPr lang="en-US" sz="3000" b="1" dirty="0">
                 <a:solidFill>
-                  <a:srgbClr val="ECECF4"/>
+                  <a:srgbClr val="111B21"/>
                 </a:solidFill>
                 <a:latin typeface="Calibri" pitchFamily="34" charset="0"/>
                 <a:ea typeface="Calibri" pitchFamily="34" charset="-122"/>
@@ -2434,7 +2463,7 @@
             <a:r>
               <a:rPr lang="en-US" sz="3000" b="1" dirty="0">
                 <a:solidFill>
-                  <a:srgbClr val="ECECF4"/>
+                  <a:srgbClr val="111B21"/>
                 </a:solidFill>
                 <a:latin typeface="Calibri" pitchFamily="34" charset="0"/>
                 <a:ea typeface="Calibri" pitchFamily="34" charset="-122"/>
@@ -2454,7 +2483,7 @@
             <a:r>
               <a:rPr lang="en-US" sz="3000" b="1" dirty="0">
                 <a:solidFill>
-                  <a:srgbClr val="FF7AA8"/>
+                  <a:srgbClr val="EA4335"/>
                 </a:solidFill>
                 <a:latin typeface="Calibri" pitchFamily="34" charset="0"/>
                 <a:ea typeface="Calibri" pitchFamily="34" charset="-122"/>
@@ -2471,7 +2500,7 @@
             <a:r>
               <a:rPr lang="en-US" sz="3000" b="1" dirty="0">
                 <a:solidFill>
-                  <a:srgbClr val="ECECF4"/>
+                  <a:srgbClr val="111B21"/>
                 </a:solidFill>
                 <a:latin typeface="Calibri" pitchFamily="34" charset="0"/>
                 <a:ea typeface="Calibri" pitchFamily="34" charset="-122"/>
@@ -2510,7 +2539,7 @@
             <a:r>
               <a:rPr lang="en-US" sz="1800" dirty="0">
                 <a:solidFill>
-                  <a:srgbClr val="B14DFF"/>
+                  <a:srgbClr val="25D366"/>
                 </a:solidFill>
                 <a:latin typeface="Calibri" pitchFamily="34" charset="0"/>
                 <a:ea typeface="Calibri" pitchFamily="34" charset="-122"/>
@@ -2549,7 +2578,7 @@
             <a:r>
               <a:rPr lang="en-US" sz="1900" dirty="0">
                 <a:solidFill>
-                  <a:srgbClr val="ECECF4"/>
+                  <a:srgbClr val="111B21"/>
                 </a:solidFill>
                 <a:latin typeface="Calibri" pitchFamily="34" charset="0"/>
                 <a:ea typeface="Calibri" pitchFamily="34" charset="-122"/>
@@ -2588,7 +2617,7 @@
             <a:r>
               <a:rPr lang="en-US" sz="1800" dirty="0">
                 <a:solidFill>
-                  <a:srgbClr val="B14DFF"/>
+                  <a:srgbClr val="25D366"/>
                 </a:solidFill>
                 <a:latin typeface="Calibri" pitchFamily="34" charset="0"/>
                 <a:ea typeface="Calibri" pitchFamily="34" charset="-122"/>
@@ -2627,7 +2656,7 @@
             <a:r>
               <a:rPr lang="en-US" sz="1900" dirty="0">
                 <a:solidFill>
-                  <a:srgbClr val="ECECF4"/>
+                  <a:srgbClr val="111B21"/>
                 </a:solidFill>
                 <a:latin typeface="Calibri" pitchFamily="34" charset="0"/>
                 <a:ea typeface="Calibri" pitchFamily="34" charset="-122"/>
@@ -2666,7 +2695,7 @@
             <a:r>
               <a:rPr lang="en-US" sz="1800" dirty="0">
                 <a:solidFill>
-                  <a:srgbClr val="B14DFF"/>
+                  <a:srgbClr val="25D366"/>
                 </a:solidFill>
                 <a:latin typeface="Calibri" pitchFamily="34" charset="0"/>
                 <a:ea typeface="Calibri" pitchFamily="34" charset="-122"/>
@@ -2705,7 +2734,7 @@
             <a:r>
               <a:rPr lang="en-US" sz="1900" dirty="0">
                 <a:solidFill>
-                  <a:srgbClr val="ECECF4"/>
+                  <a:srgbClr val="111B21"/>
                 </a:solidFill>
                 <a:latin typeface="Calibri" pitchFamily="34" charset="0"/>
                 <a:ea typeface="Calibri" pitchFamily="34" charset="-122"/>
@@ -2744,7 +2773,7 @@
             <a:r>
               <a:rPr lang="en-US" sz="1400" dirty="0">
                 <a:solidFill>
-                  <a:srgbClr val="9A9AB4"/>
+                  <a:srgbClr val="5B6B66"/>
                 </a:solidFill>
                 <a:latin typeface="Calibri" pitchFamily="34" charset="0"/>
                 <a:ea typeface="Calibri" pitchFamily="34" charset="-122"/>
@@ -2770,7 +2799,7 @@
     <p:bg>
       <p:bgPr>
         <a:solidFill>
-          <a:srgbClr val="0D0D12"/>
+          <a:srgbClr val="EEF1EC"/>
         </a:solidFill>
       </p:bgPr>
     </p:bg>
@@ -2815,7 +2844,7 @@
             <a:r>
               <a:rPr lang="en-US" sz="3800" b="1" spc="-50" kern="0" dirty="0">
                 <a:solidFill>
-                  <a:srgbClr val="ECECF4"/>
+                  <a:srgbClr val="111B21"/>
                 </a:solidFill>
                 <a:latin typeface="Calibri" pitchFamily="34" charset="0"/>
                 <a:ea typeface="Calibri" pitchFamily="34" charset="-122"/>
@@ -2844,11 +2873,11 @@
             </a:avLst>
           </a:prstGeom>
           <a:solidFill>
-            <a:srgbClr val="181823"/>
+            <a:srgbClr val="FFFFFF"/>
           </a:solidFill>
           <a:ln w="12700">
             <a:solidFill>
-              <a:srgbClr val="2A2A3A"/>
+              <a:srgbClr val="E2DDD5"/>
             </a:solidFill>
             <a:prstDash val="solid"/>
           </a:ln>
@@ -2869,11 +2898,11 @@
             <a:avLst/>
           </a:prstGeom>
           <a:solidFill>
-            <a:srgbClr val="46D398"/>
+            <a:srgbClr val="25D366"/>
           </a:solidFill>
           <a:ln w="12700">
             <a:solidFill>
-              <a:srgbClr val="46D398"/>
+              <a:srgbClr val="25D366"/>
             </a:solidFill>
             <a:prstDash val="solid"/>
           </a:ln>
@@ -2906,7 +2935,7 @@
             <a:r>
               <a:rPr lang="en-US" sz="1700" b="1" dirty="0">
                 <a:solidFill>
-                  <a:srgbClr val="ECECF4"/>
+                  <a:srgbClr val="111B21"/>
                 </a:solidFill>
                 <a:latin typeface="Calibri" pitchFamily="34" charset="0"/>
                 <a:ea typeface="Calibri" pitchFamily="34" charset="-122"/>
@@ -2945,7 +2974,7 @@
             <a:r>
               <a:rPr lang="en-US" sz="1300" dirty="0">
                 <a:solidFill>
-                  <a:srgbClr val="9A9AB4"/>
+                  <a:srgbClr val="5B6B66"/>
                 </a:solidFill>
                 <a:latin typeface="Calibri" pitchFamily="34" charset="0"/>
                 <a:ea typeface="Calibri" pitchFamily="34" charset="-122"/>
@@ -2974,11 +3003,11 @@
             </a:avLst>
           </a:prstGeom>
           <a:solidFill>
-            <a:srgbClr val="181823"/>
+            <a:srgbClr val="FFFFFF"/>
           </a:solidFill>
           <a:ln w="12700">
             <a:solidFill>
-              <a:srgbClr val="2A2A3A"/>
+              <a:srgbClr val="E2DDD5"/>
             </a:solidFill>
             <a:prstDash val="solid"/>
           </a:ln>
@@ -2999,11 +3028,11 @@
             <a:avLst/>
           </a:prstGeom>
           <a:solidFill>
-            <a:srgbClr val="FFB454"/>
+            <a:srgbClr val="F4A300"/>
           </a:solidFill>
           <a:ln w="12700">
             <a:solidFill>
-              <a:srgbClr val="FFB454"/>
+              <a:srgbClr val="F4A300"/>
             </a:solidFill>
             <a:prstDash val="solid"/>
           </a:ln>
@@ -3036,7 +3065,7 @@
             <a:r>
               <a:rPr lang="en-US" sz="1700" b="1" dirty="0">
                 <a:solidFill>
-                  <a:srgbClr val="ECECF4"/>
+                  <a:srgbClr val="111B21"/>
                 </a:solidFill>
                 <a:latin typeface="Calibri" pitchFamily="34" charset="0"/>
                 <a:ea typeface="Calibri" pitchFamily="34" charset="-122"/>
@@ -3075,7 +3104,7 @@
             <a:r>
               <a:rPr lang="en-US" sz="1300" dirty="0">
                 <a:solidFill>
-                  <a:srgbClr val="9A9AB4"/>
+                  <a:srgbClr val="5B6B66"/>
                 </a:solidFill>
                 <a:latin typeface="Calibri" pitchFamily="34" charset="0"/>
                 <a:ea typeface="Calibri" pitchFamily="34" charset="-122"/>
@@ -3104,11 +3133,11 @@
             </a:avLst>
           </a:prstGeom>
           <a:solidFill>
-            <a:srgbClr val="181823"/>
+            <a:srgbClr val="FFFFFF"/>
           </a:solidFill>
           <a:ln w="12700">
             <a:solidFill>
-              <a:srgbClr val="2A2A3A"/>
+              <a:srgbClr val="E2DDD5"/>
             </a:solidFill>
             <a:prstDash val="solid"/>
           </a:ln>
@@ -3129,11 +3158,11 @@
             <a:avLst/>
           </a:prstGeom>
           <a:solidFill>
-            <a:srgbClr val="6AA8FF"/>
+            <a:srgbClr val="34B7F1"/>
           </a:solidFill>
           <a:ln w="12700">
             <a:solidFill>
-              <a:srgbClr val="6AA8FF"/>
+              <a:srgbClr val="34B7F1"/>
             </a:solidFill>
             <a:prstDash val="solid"/>
           </a:ln>
@@ -3166,7 +3195,7 @@
             <a:r>
               <a:rPr lang="en-US" sz="1700" b="1" dirty="0">
                 <a:solidFill>
-                  <a:srgbClr val="ECECF4"/>
+                  <a:srgbClr val="111B21"/>
                 </a:solidFill>
                 <a:latin typeface="Calibri" pitchFamily="34" charset="0"/>
                 <a:ea typeface="Calibri" pitchFamily="34" charset="-122"/>
@@ -3205,7 +3234,7 @@
             <a:r>
               <a:rPr lang="en-US" sz="1300" dirty="0">
                 <a:solidFill>
-                  <a:srgbClr val="9A9AB4"/>
+                  <a:srgbClr val="5B6B66"/>
                 </a:solidFill>
                 <a:latin typeface="Calibri" pitchFamily="34" charset="0"/>
                 <a:ea typeface="Calibri" pitchFamily="34" charset="-122"/>
@@ -3234,11 +3263,11 @@
             </a:avLst>
           </a:prstGeom>
           <a:solidFill>
-            <a:srgbClr val="181823"/>
+            <a:srgbClr val="FFFFFF"/>
           </a:solidFill>
           <a:ln w="12700">
             <a:solidFill>
-              <a:srgbClr val="2A2A3A"/>
+              <a:srgbClr val="E2DDD5"/>
             </a:solidFill>
             <a:prstDash val="solid"/>
           </a:ln>
@@ -3259,11 +3288,11 @@
             <a:avLst/>
           </a:prstGeom>
           <a:solidFill>
-            <a:srgbClr val="D27DFF"/>
+            <a:srgbClr val="128C7E"/>
           </a:solidFill>
           <a:ln w="12700">
             <a:solidFill>
-              <a:srgbClr val="D27DFF"/>
+              <a:srgbClr val="128C7E"/>
             </a:solidFill>
             <a:prstDash val="solid"/>
           </a:ln>
@@ -3296,7 +3325,7 @@
             <a:r>
               <a:rPr lang="en-US" sz="1700" b="1" dirty="0">
                 <a:solidFill>
-                  <a:srgbClr val="ECECF4"/>
+                  <a:srgbClr val="111B21"/>
                 </a:solidFill>
                 <a:latin typeface="Calibri" pitchFamily="34" charset="0"/>
                 <a:ea typeface="Calibri" pitchFamily="34" charset="-122"/>
@@ -3335,7 +3364,7 @@
             <a:r>
               <a:rPr lang="en-US" sz="1300" dirty="0">
                 <a:solidFill>
-                  <a:srgbClr val="9A9AB4"/>
+                  <a:srgbClr val="5B6B66"/>
                 </a:solidFill>
                 <a:latin typeface="Calibri" pitchFamily="34" charset="0"/>
                 <a:ea typeface="Calibri" pitchFamily="34" charset="-122"/>
@@ -3364,11 +3393,11 @@
             </a:avLst>
           </a:prstGeom>
           <a:solidFill>
-            <a:srgbClr val="181823"/>
+            <a:srgbClr val="FFFFFF"/>
           </a:solidFill>
           <a:ln w="12700">
             <a:solidFill>
-              <a:srgbClr val="2A2A3A"/>
+              <a:srgbClr val="E2DDD5"/>
             </a:solidFill>
             <a:prstDash val="solid"/>
           </a:ln>
@@ -3389,11 +3418,11 @@
             <a:avLst/>
           </a:prstGeom>
           <a:solidFill>
-            <a:srgbClr val="45D0D0"/>
+            <a:srgbClr val="008069"/>
           </a:solidFill>
           <a:ln w="12700">
             <a:solidFill>
-              <a:srgbClr val="45D0D0"/>
+              <a:srgbClr val="008069"/>
             </a:solidFill>
             <a:prstDash val="solid"/>
           </a:ln>
@@ -3426,7 +3455,7 @@
             <a:r>
               <a:rPr lang="en-US" sz="1700" b="1" dirty="0">
                 <a:solidFill>
-                  <a:srgbClr val="ECECF4"/>
+                  <a:srgbClr val="111B21"/>
                 </a:solidFill>
                 <a:latin typeface="Calibri" pitchFamily="34" charset="0"/>
                 <a:ea typeface="Calibri" pitchFamily="34" charset="-122"/>
@@ -3465,7 +3494,7 @@
             <a:r>
               <a:rPr lang="en-US" sz="1300" dirty="0">
                 <a:solidFill>
-                  <a:srgbClr val="9A9AB4"/>
+                  <a:srgbClr val="5B6B66"/>
                 </a:solidFill>
                 <a:latin typeface="Calibri" pitchFamily="34" charset="0"/>
                 <a:ea typeface="Calibri" pitchFamily="34" charset="-122"/>
@@ -3491,7 +3520,7 @@
     <p:bg>
       <p:bgPr>
         <a:solidFill>
-          <a:srgbClr val="0D0D12"/>
+          <a:srgbClr val="EEF1EC"/>
         </a:solidFill>
       </p:bgPr>
     </p:bg>
@@ -3536,7 +3565,7 @@
             <a:r>
               <a:rPr lang="en-US" sz="3800" b="1" spc="-50" kern="0" dirty="0">
                 <a:solidFill>
-                  <a:srgbClr val="ECECF4"/>
+                  <a:srgbClr val="111B21"/>
                 </a:solidFill>
                 <a:latin typeface="Calibri" pitchFamily="34" charset="0"/>
                 <a:ea typeface="Calibri" pitchFamily="34" charset="-122"/>
@@ -3565,11 +3594,11 @@
             </a:avLst>
           </a:prstGeom>
           <a:solidFill>
-            <a:srgbClr val="11111A"/>
+            <a:srgbClr val="0B1F1A"/>
           </a:solidFill>
           <a:ln w="12700">
             <a:solidFill>
-              <a:srgbClr val="2A2A3A"/>
+              <a:srgbClr val="1D3B34"/>
             </a:solidFill>
             <a:prstDash val="solid"/>
           </a:ln>
@@ -3605,7 +3634,7 @@
             <a:r>
               <a:rPr lang="en-US" sz="1350" dirty="0">
                 <a:solidFill>
-                  <a:srgbClr val="6B6B85"/>
+                  <a:srgbClr val="6F857D"/>
                 </a:solidFill>
                 <a:latin typeface="Courier New" pitchFamily="34" charset="0"/>
                 <a:ea typeface="Courier New" pitchFamily="34" charset="-122"/>
@@ -3623,7 +3652,7 @@
             <a:r>
               <a:rPr lang="en-US" sz="1350" b="1" dirty="0">
                 <a:solidFill>
-                  <a:srgbClr val="B14DFF"/>
+                  <a:srgbClr val="25D366"/>
                 </a:solidFill>
                 <a:latin typeface="Courier New" pitchFamily="34" charset="0"/>
                 <a:ea typeface="Courier New" pitchFamily="34" charset="-122"/>
@@ -3640,7 +3669,7 @@
             <a:r>
               <a:rPr lang="en-US" sz="1350" dirty="0">
                 <a:solidFill>
-                  <a:srgbClr val="ECECF4"/>
+                  <a:srgbClr val="D7E3DF"/>
                 </a:solidFill>
                 <a:latin typeface="Courier New" pitchFamily="34" charset="0"/>
                 <a:ea typeface="Courier New" pitchFamily="34" charset="-122"/>
@@ -3658,7 +3687,7 @@
             <a:r>
               <a:rPr lang="en-US" sz="1350" dirty="0">
                 <a:solidFill>
-                  <a:srgbClr val="3A3A52"/>
+                  <a:srgbClr val="355C52"/>
                 </a:solidFill>
                 <a:latin typeface="Courier New" pitchFamily="34" charset="0"/>
                 <a:ea typeface="Courier New" pitchFamily="34" charset="-122"/>
@@ -3676,7 +3705,7 @@
             <a:r>
               <a:rPr lang="en-US" sz="1350" dirty="0">
                 <a:solidFill>
-                  <a:srgbClr val="FF5D6C"/>
+                  <a:srgbClr val="FF6B6B"/>
                 </a:solidFill>
                 <a:latin typeface="Courier New" pitchFamily="34" charset="0"/>
                 <a:ea typeface="Courier New" pitchFamily="34" charset="-122"/>
@@ -3693,7 +3722,7 @@
             <a:r>
               <a:rPr lang="en-US" sz="1350" dirty="0">
                 <a:solidFill>
-                  <a:srgbClr val="ECECF4"/>
+                  <a:srgbClr val="D7E3DF"/>
                 </a:solidFill>
                 <a:latin typeface="Courier New" pitchFamily="34" charset="0"/>
                 <a:ea typeface="Courier New" pitchFamily="34" charset="-122"/>
@@ -3711,7 +3740,7 @@
             <a:r>
               <a:rPr lang="en-US" sz="1350" dirty="0">
                 <a:solidFill>
-                  <a:srgbClr val="FFB454"/>
+                  <a:srgbClr val="F4A300"/>
                 </a:solidFill>
                 <a:latin typeface="Courier New" pitchFamily="34" charset="0"/>
                 <a:ea typeface="Courier New" pitchFamily="34" charset="-122"/>
@@ -3728,7 +3757,7 @@
             <a:r>
               <a:rPr lang="en-US" sz="1350" dirty="0">
                 <a:solidFill>
-                  <a:srgbClr val="ECECF4"/>
+                  <a:srgbClr val="D7E3DF"/>
                 </a:solidFill>
                 <a:latin typeface="Courier New" pitchFamily="34" charset="0"/>
                 <a:ea typeface="Courier New" pitchFamily="34" charset="-122"/>
@@ -3746,7 +3775,7 @@
             <a:r>
               <a:rPr lang="en-US" sz="1350" dirty="0">
                 <a:solidFill>
-                  <a:srgbClr val="6AA8FF"/>
+                  <a:srgbClr val="34B7F1"/>
                 </a:solidFill>
                 <a:latin typeface="Courier New" pitchFamily="34" charset="0"/>
                 <a:ea typeface="Courier New" pitchFamily="34" charset="-122"/>
@@ -3763,7 +3792,7 @@
             <a:r>
               <a:rPr lang="en-US" sz="1350" dirty="0">
                 <a:solidFill>
-                  <a:srgbClr val="ECECF4"/>
+                  <a:srgbClr val="D7E3DF"/>
                 </a:solidFill>
                 <a:latin typeface="Courier New" pitchFamily="34" charset="0"/>
                 <a:ea typeface="Courier New" pitchFamily="34" charset="-122"/>
@@ -3781,7 +3810,7 @@
             <a:r>
               <a:rPr lang="en-US" sz="1350" dirty="0">
                 <a:solidFill>
-                  <a:srgbClr val="45D0D0"/>
+                  <a:srgbClr val="25D366"/>
                 </a:solidFill>
                 <a:latin typeface="Courier New" pitchFamily="34" charset="0"/>
                 <a:ea typeface="Courier New" pitchFamily="34" charset="-122"/>
@@ -3798,7 +3827,7 @@
             <a:r>
               <a:rPr lang="en-US" sz="1350" dirty="0">
                 <a:solidFill>
-                  <a:srgbClr val="ECECF4"/>
+                  <a:srgbClr val="D7E3DF"/>
                 </a:solidFill>
                 <a:latin typeface="Courier New" pitchFamily="34" charset="0"/>
                 <a:ea typeface="Courier New" pitchFamily="34" charset="-122"/>
@@ -3816,7 +3845,7 @@
             <a:r>
               <a:rPr lang="en-US" sz="1350" dirty="0">
                 <a:solidFill>
-                  <a:srgbClr val="3A3A52"/>
+                  <a:srgbClr val="355C52"/>
                 </a:solidFill>
                 <a:latin typeface="Courier New" pitchFamily="34" charset="0"/>
                 <a:ea typeface="Courier New" pitchFamily="34" charset="-122"/>
@@ -3834,7 +3863,7 @@
             <a:r>
               <a:rPr lang="en-US" sz="1350" dirty="0">
                 <a:solidFill>
-                  <a:srgbClr val="ECECF4"/>
+                  <a:srgbClr val="D7E3DF"/>
                 </a:solidFill>
                 <a:latin typeface="Courier New" pitchFamily="34" charset="0"/>
                 <a:ea typeface="Courier New" pitchFamily="34" charset="-122"/>
@@ -3851,7 +3880,7 @@
             <a:r>
               <a:rPr lang="en-US" sz="1350" dirty="0">
                 <a:solidFill>
-                  <a:srgbClr val="B14DFF"/>
+                  <a:srgbClr val="25D366"/>
                 </a:solidFill>
                 <a:latin typeface="Courier New" pitchFamily="34" charset="0"/>
                 <a:ea typeface="Courier New" pitchFamily="34" charset="-122"/>
@@ -3868,7 +3897,7 @@
             <a:r>
               <a:rPr lang="en-US" sz="1350" dirty="0">
                 <a:solidFill>
-                  <a:srgbClr val="6B6B85"/>
+                  <a:srgbClr val="6F857D"/>
                 </a:solidFill>
                 <a:latin typeface="Courier New" pitchFamily="34" charset="0"/>
                 <a:ea typeface="Courier New" pitchFamily="34" charset="-122"/>
@@ -3886,7 +3915,7 @@
             <a:r>
               <a:rPr lang="en-US" sz="1350" dirty="0">
                 <a:solidFill>
-                  <a:srgbClr val="ECECF4"/>
+                  <a:srgbClr val="D7E3DF"/>
                 </a:solidFill>
                 <a:latin typeface="Courier New" pitchFamily="34" charset="0"/>
                 <a:ea typeface="Courier New" pitchFamily="34" charset="-122"/>
@@ -3903,7 +3932,7 @@
             <a:r>
               <a:rPr lang="en-US" sz="1350" b="1" dirty="0">
                 <a:solidFill>
-                  <a:srgbClr val="FF5D6C"/>
+                  <a:srgbClr val="FF6B6B"/>
                 </a:solidFill>
                 <a:latin typeface="Courier New" pitchFamily="34" charset="0"/>
                 <a:ea typeface="Courier New" pitchFamily="34" charset="-122"/>
@@ -3920,7 +3949,7 @@
             <a:r>
               <a:rPr lang="en-US" sz="1350" dirty="0">
                 <a:solidFill>
-                  <a:srgbClr val="ECECF4"/>
+                  <a:srgbClr val="D7E3DF"/>
                 </a:solidFill>
                 <a:latin typeface="Courier New" pitchFamily="34" charset="0"/>
                 <a:ea typeface="Courier New" pitchFamily="34" charset="-122"/>
@@ -3959,7 +3988,7 @@
             <a:r>
               <a:rPr lang="en-US" sz="1400" dirty="0">
                 <a:solidFill>
-                  <a:srgbClr val="9A9AB4"/>
+                  <a:srgbClr val="5B6B66"/>
                 </a:solidFill>
                 <a:latin typeface="Calibri" pitchFamily="34" charset="0"/>
                 <a:ea typeface="Calibri" pitchFamily="34" charset="-122"/>
@@ -3985,7 +4014,7 @@
     <p:bg>
       <p:bgPr>
         <a:solidFill>
-          <a:srgbClr val="0D0D12"/>
+          <a:srgbClr val="EEF1EC"/>
         </a:solidFill>
       </p:bgPr>
     </p:bg>
@@ -4030,7 +4059,7 @@
             <a:r>
               <a:rPr lang="en-US" sz="3800" b="1" spc="-50" kern="0" dirty="0">
                 <a:solidFill>
-                  <a:srgbClr val="ECECF4"/>
+                  <a:srgbClr val="111B21"/>
                 </a:solidFill>
                 <a:latin typeface="Calibri" pitchFamily="34" charset="0"/>
                 <a:ea typeface="Calibri" pitchFamily="34" charset="-122"/>
@@ -4069,7 +4098,7 @@
             <a:r>
               <a:rPr lang="en-US" sz="1800" dirty="0">
                 <a:solidFill>
-                  <a:srgbClr val="9A9AB4"/>
+                  <a:srgbClr val="5B6B66"/>
                 </a:solidFill>
                 <a:latin typeface="Calibri" pitchFamily="34" charset="0"/>
                 <a:ea typeface="Calibri" pitchFamily="34" charset="-122"/>
@@ -4098,11 +4127,11 @@
             </a:avLst>
           </a:prstGeom>
           <a:solidFill>
-            <a:srgbClr val="11111A"/>
+            <a:srgbClr val="0B1F1A"/>
           </a:solidFill>
           <a:ln w="12700">
             <a:solidFill>
-              <a:srgbClr val="2A2A3A"/>
+              <a:srgbClr val="1D3B34"/>
             </a:solidFill>
             <a:prstDash val="solid"/>
           </a:ln>
@@ -4138,7 +4167,7 @@
             <a:r>
               <a:rPr lang="en-US" sz="1700" dirty="0">
                 <a:solidFill>
-                  <a:srgbClr val="ECECF4"/>
+                  <a:srgbClr val="D7E3DF"/>
                 </a:solidFill>
                 <a:latin typeface="Courier New" pitchFamily="34" charset="0"/>
                 <a:ea typeface="Courier New" pitchFamily="34" charset="-122"/>
@@ -4155,7 +4184,7 @@
             <a:r>
               <a:rPr lang="en-US" sz="1700" dirty="0">
                 <a:solidFill>
-                  <a:srgbClr val="46D398"/>
+                  <a:srgbClr val="25D366"/>
                 </a:solidFill>
                 <a:latin typeface="Courier New" pitchFamily="34" charset="0"/>
                 <a:ea typeface="Courier New" pitchFamily="34" charset="-122"/>
@@ -4173,7 +4202,7 @@
             <a:r>
               <a:rPr lang="en-US" sz="1700" dirty="0">
                 <a:solidFill>
-                  <a:srgbClr val="ECECF4"/>
+                  <a:srgbClr val="D7E3DF"/>
                 </a:solidFill>
                 <a:latin typeface="Courier New" pitchFamily="34" charset="0"/>
                 <a:ea typeface="Courier New" pitchFamily="34" charset="-122"/>
@@ -4190,7 +4219,7 @@
             <a:r>
               <a:rPr lang="en-US" sz="1700" dirty="0">
                 <a:solidFill>
-                  <a:srgbClr val="45D0D0"/>
+                  <a:srgbClr val="128C7E"/>
                 </a:solidFill>
                 <a:latin typeface="Courier New" pitchFamily="34" charset="0"/>
                 <a:ea typeface="Courier New" pitchFamily="34" charset="-122"/>
@@ -4208,7 +4237,7 @@
             <a:r>
               <a:rPr lang="en-US" sz="1700" dirty="0">
                 <a:solidFill>
-                  <a:srgbClr val="ECECF4"/>
+                  <a:srgbClr val="D7E3DF"/>
                 </a:solidFill>
                 <a:latin typeface="Courier New" pitchFamily="34" charset="0"/>
                 <a:ea typeface="Courier New" pitchFamily="34" charset="-122"/>
@@ -4225,7 +4254,7 @@
             <a:r>
               <a:rPr lang="en-US" sz="1700" dirty="0">
                 <a:solidFill>
-                  <a:srgbClr val="D27DFF"/>
+                  <a:srgbClr val="34B7F1"/>
                 </a:solidFill>
                 <a:latin typeface="Courier New" pitchFamily="34" charset="0"/>
                 <a:ea typeface="Courier New" pitchFamily="34" charset="-122"/>
@@ -4243,7 +4272,7 @@
             <a:r>
               <a:rPr lang="en-US" sz="1700" dirty="0">
                 <a:solidFill>
-                  <a:srgbClr val="ECECF4"/>
+                  <a:srgbClr val="D7E3DF"/>
                 </a:solidFill>
                 <a:latin typeface="Courier New" pitchFamily="34" charset="0"/>
                 <a:ea typeface="Courier New" pitchFamily="34" charset="-122"/>
@@ -4260,7 +4289,7 @@
             <a:r>
               <a:rPr lang="en-US" sz="1700" dirty="0">
                 <a:solidFill>
-                  <a:srgbClr val="6AA8FF"/>
+                  <a:srgbClr val="1FB58E"/>
                 </a:solidFill>
                 <a:latin typeface="Courier New" pitchFamily="34" charset="0"/>
                 <a:ea typeface="Courier New" pitchFamily="34" charset="-122"/>
@@ -4278,7 +4307,7 @@
             <a:r>
               <a:rPr lang="en-US" sz="1700" dirty="0">
                 <a:solidFill>
-                  <a:srgbClr val="ECECF4"/>
+                  <a:srgbClr val="D7E3DF"/>
                 </a:solidFill>
                 <a:latin typeface="Courier New" pitchFamily="34" charset="0"/>
                 <a:ea typeface="Courier New" pitchFamily="34" charset="-122"/>
@@ -4295,7 +4324,7 @@
             <a:r>
               <a:rPr lang="en-US" sz="1700" dirty="0">
                 <a:solidFill>
-                  <a:srgbClr val="FFB454"/>
+                  <a:srgbClr val="F4A300"/>
                 </a:solidFill>
                 <a:latin typeface="Courier New" pitchFamily="34" charset="0"/>
                 <a:ea typeface="Courier New" pitchFamily="34" charset="-122"/>
@@ -4312,7 +4341,7 @@
             <a:r>
               <a:rPr lang="en-US" sz="1700" dirty="0">
                 <a:solidFill>
-                  <a:srgbClr val="ECECF4"/>
+                  <a:srgbClr val="D7E3DF"/>
                 </a:solidFill>
                 <a:latin typeface="Courier New" pitchFamily="34" charset="0"/>
                 <a:ea typeface="Courier New" pitchFamily="34" charset="-122"/>
@@ -4351,7 +4380,7 @@
             <a:r>
               <a:rPr lang="en-US" sz="1400" dirty="0">
                 <a:solidFill>
-                  <a:srgbClr val="9A9AB4"/>
+                  <a:srgbClr val="5B6B66"/>
                 </a:solidFill>
                 <a:latin typeface="Calibri" pitchFamily="34" charset="0"/>
                 <a:ea typeface="Calibri" pitchFamily="34" charset="-122"/>
@@ -4377,7 +4406,7 @@
     <p:bg>
       <p:bgPr>
         <a:solidFill>
-          <a:srgbClr val="0D0D12"/>
+          <a:srgbClr val="EEF1EC"/>
         </a:solidFill>
       </p:bgPr>
     </p:bg>
@@ -4422,7 +4451,7 @@
             <a:r>
               <a:rPr lang="en-US" sz="3800" b="1" spc="-50" kern="0" dirty="0">
                 <a:solidFill>
-                  <a:srgbClr val="ECECF4"/>
+                  <a:srgbClr val="111B21"/>
                 </a:solidFill>
                 <a:latin typeface="Calibri" pitchFamily="34" charset="0"/>
                 <a:ea typeface="Calibri" pitchFamily="34" charset="-122"/>
@@ -4461,7 +4490,7 @@
             <a:r>
               <a:rPr lang="en-US" sz="3600" b="1" dirty="0">
                 <a:solidFill>
-                  <a:srgbClr val="ECECF4"/>
+                  <a:srgbClr val="111B21"/>
                 </a:solidFill>
                 <a:latin typeface="Calibri" pitchFamily="34" charset="0"/>
                 <a:ea typeface="Calibri" pitchFamily="34" charset="-122"/>
@@ -4475,7 +4504,7 @@
             <a:r>
               <a:rPr lang="en-US" sz="3600" b="1" dirty="0">
                 <a:solidFill>
-                  <a:srgbClr val="FF7AA8"/>
+                  <a:srgbClr val="008069"/>
                 </a:solidFill>
                 <a:latin typeface="Calibri" pitchFamily="34" charset="0"/>
                 <a:ea typeface="Calibri" pitchFamily="34" charset="-122"/>
@@ -4504,11 +4533,11 @@
             </a:avLst>
           </a:prstGeom>
           <a:solidFill>
-            <a:srgbClr val="181823"/>
+            <a:srgbClr val="FFFFFF"/>
           </a:solidFill>
           <a:ln w="12700">
             <a:solidFill>
-              <a:srgbClr val="2A2A3A"/>
+              <a:srgbClr val="E2DDD5"/>
             </a:solidFill>
             <a:prstDash val="solid"/>
           </a:ln>
@@ -4541,7 +4570,7 @@
             <a:r>
               <a:rPr lang="en-US" sz="1400" dirty="0">
                 <a:solidFill>
-                  <a:srgbClr val="ECECF4"/>
+                  <a:srgbClr val="111B21"/>
                 </a:solidFill>
                 <a:latin typeface="Calibri" pitchFamily="34" charset="0"/>
                 <a:ea typeface="Calibri" pitchFamily="34" charset="-122"/>
@@ -4570,11 +4599,11 @@
             </a:avLst>
           </a:prstGeom>
           <a:solidFill>
-            <a:srgbClr val="181823"/>
+            <a:srgbClr val="FFFFFF"/>
           </a:solidFill>
           <a:ln w="12700">
             <a:solidFill>
-              <a:srgbClr val="2A2A3A"/>
+              <a:srgbClr val="E2DDD5"/>
             </a:solidFill>
             <a:prstDash val="solid"/>
           </a:ln>
@@ -4607,7 +4636,7 @@
             <a:r>
               <a:rPr lang="en-US" sz="1400" dirty="0">
                 <a:solidFill>
-                  <a:srgbClr val="ECECF4"/>
+                  <a:srgbClr val="111B21"/>
                 </a:solidFill>
                 <a:latin typeface="Calibri" pitchFamily="34" charset="0"/>
                 <a:ea typeface="Calibri" pitchFamily="34" charset="-122"/>
@@ -4636,11 +4665,11 @@
             </a:avLst>
           </a:prstGeom>
           <a:solidFill>
-            <a:srgbClr val="181823"/>
+            <a:srgbClr val="FFFFFF"/>
           </a:solidFill>
           <a:ln w="12700">
             <a:solidFill>
-              <a:srgbClr val="2A2A3A"/>
+              <a:srgbClr val="E2DDD5"/>
             </a:solidFill>
             <a:prstDash val="solid"/>
           </a:ln>
@@ -4673,7 +4702,7 @@
             <a:r>
               <a:rPr lang="en-US" sz="1400" dirty="0">
                 <a:solidFill>
-                  <a:srgbClr val="ECECF4"/>
+                  <a:srgbClr val="111B21"/>
                 </a:solidFill>
                 <a:latin typeface="Calibri" pitchFamily="34" charset="0"/>
                 <a:ea typeface="Calibri" pitchFamily="34" charset="-122"/>
@@ -4702,11 +4731,11 @@
             </a:avLst>
           </a:prstGeom>
           <a:solidFill>
-            <a:srgbClr val="181823"/>
+            <a:srgbClr val="FFFFFF"/>
           </a:solidFill>
           <a:ln w="12700">
             <a:solidFill>
-              <a:srgbClr val="2A2A3A"/>
+              <a:srgbClr val="E2DDD5"/>
             </a:solidFill>
             <a:prstDash val="solid"/>
           </a:ln>
@@ -4739,7 +4768,7 @@
             <a:r>
               <a:rPr lang="en-US" sz="1400" dirty="0">
                 <a:solidFill>
-                  <a:srgbClr val="ECECF4"/>
+                  <a:srgbClr val="111B21"/>
                 </a:solidFill>
                 <a:latin typeface="Calibri" pitchFamily="34" charset="0"/>
                 <a:ea typeface="Calibri" pitchFamily="34" charset="-122"/>
@@ -4768,11 +4797,11 @@
             </a:avLst>
           </a:prstGeom>
           <a:solidFill>
-            <a:srgbClr val="181823"/>
+            <a:srgbClr val="FFFFFF"/>
           </a:solidFill>
           <a:ln w="12700">
             <a:solidFill>
-              <a:srgbClr val="2A2A3A"/>
+              <a:srgbClr val="E2DDD5"/>
             </a:solidFill>
             <a:prstDash val="solid"/>
           </a:ln>
@@ -4805,7 +4834,7 @@
             <a:r>
               <a:rPr lang="en-US" sz="1400" dirty="0">
                 <a:solidFill>
-                  <a:srgbClr val="ECECF4"/>
+                  <a:srgbClr val="111B21"/>
                 </a:solidFill>
                 <a:latin typeface="Calibri" pitchFamily="34" charset="0"/>
                 <a:ea typeface="Calibri" pitchFamily="34" charset="-122"/>
@@ -4834,11 +4863,11 @@
             </a:avLst>
           </a:prstGeom>
           <a:solidFill>
-            <a:srgbClr val="181823"/>
+            <a:srgbClr val="FFFFFF"/>
           </a:solidFill>
           <a:ln w="12700">
             <a:solidFill>
-              <a:srgbClr val="2A2A3A"/>
+              <a:srgbClr val="E2DDD5"/>
             </a:solidFill>
             <a:prstDash val="solid"/>
           </a:ln>
@@ -4871,7 +4900,7 @@
             <a:r>
               <a:rPr lang="en-US" sz="1400" dirty="0">
                 <a:solidFill>
-                  <a:srgbClr val="ECECF4"/>
+                  <a:srgbClr val="111B21"/>
                 </a:solidFill>
                 <a:latin typeface="Calibri" pitchFamily="34" charset="0"/>
                 <a:ea typeface="Calibri" pitchFamily="34" charset="-122"/>
@@ -4910,7 +4939,7 @@
             <a:r>
               <a:rPr lang="en-US" sz="1600" dirty="0">
                 <a:solidFill>
-                  <a:srgbClr val="9A9AB4"/>
+                  <a:srgbClr val="5B6B66"/>
                 </a:solidFill>
                 <a:latin typeface="Calibri" pitchFamily="34" charset="0"/>
                 <a:ea typeface="Calibri" pitchFamily="34" charset="-122"/>
@@ -4924,7 +4953,7 @@
             <a:r>
               <a:rPr lang="en-US" sz="1600" b="1" dirty="0">
                 <a:solidFill>
-                  <a:srgbClr val="ECECF4"/>
+                  <a:srgbClr val="111B21"/>
                 </a:solidFill>
                 <a:latin typeface="Calibri" pitchFamily="34" charset="0"/>
                 <a:ea typeface="Calibri" pitchFamily="34" charset="-122"/>
@@ -4938,7 +4967,7 @@
             <a:r>
               <a:rPr lang="en-US" sz="1600" dirty="0">
                 <a:solidFill>
-                  <a:srgbClr val="9A9AB4"/>
+                  <a:srgbClr val="5B6B66"/>
                 </a:solidFill>
                 <a:latin typeface="Calibri" pitchFamily="34" charset="0"/>
                 <a:ea typeface="Calibri" pitchFamily="34" charset="-122"/>
@@ -4964,7 +4993,7 @@
     <p:bg>
       <p:bgPr>
         <a:solidFill>
-          <a:srgbClr val="0D0D12"/>
+          <a:srgbClr val="EEF1EC"/>
         </a:solidFill>
       </p:bgPr>
     </p:bg>
@@ -5009,7 +5038,7 @@
             <a:r>
               <a:rPr lang="en-US" sz="3800" b="1" spc="-50" kern="0" dirty="0">
                 <a:solidFill>
-                  <a:srgbClr val="ECECF4"/>
+                  <a:srgbClr val="111B21"/>
                 </a:solidFill>
                 <a:latin typeface="Calibri" pitchFamily="34" charset="0"/>
                 <a:ea typeface="Calibri" pitchFamily="34" charset="-122"/>
@@ -5038,11 +5067,11 @@
             </a:avLst>
           </a:prstGeom>
           <a:solidFill>
-            <a:srgbClr val="11111A"/>
+            <a:srgbClr val="0B1F1A"/>
           </a:solidFill>
           <a:ln w="12700">
             <a:solidFill>
-              <a:srgbClr val="2A2A3A"/>
+              <a:srgbClr val="1D3B34"/>
             </a:solidFill>
             <a:prstDash val="solid"/>
           </a:ln>
@@ -5078,7 +5107,7 @@
             <a:r>
               <a:rPr lang="en-US" sz="1300" dirty="0">
                 <a:solidFill>
-                  <a:srgbClr val="9A9AB4"/>
+                  <a:srgbClr val="D7E3DF"/>
                 </a:solidFill>
                 <a:latin typeface="Courier New" pitchFamily="34" charset="0"/>
                 <a:ea typeface="Courier New" pitchFamily="34" charset="-122"/>
@@ -5098,7 +5127,7 @@
             <a:r>
               <a:rPr lang="en-US" sz="1300" dirty="0">
                 <a:solidFill>
-                  <a:srgbClr val="6B6B85"/>
+                  <a:srgbClr val="6F857D"/>
                 </a:solidFill>
                 <a:latin typeface="Courier New" pitchFamily="34" charset="0"/>
                 <a:ea typeface="Courier New" pitchFamily="34" charset="-122"/>
@@ -5116,7 +5145,7 @@
             <a:r>
               <a:rPr lang="en-US" sz="1300" dirty="0">
                 <a:solidFill>
-                  <a:srgbClr val="ECECF4"/>
+                  <a:srgbClr val="D7E3DF"/>
                 </a:solidFill>
                 <a:latin typeface="Courier New" pitchFamily="34" charset="0"/>
                 <a:ea typeface="Courier New" pitchFamily="34" charset="-122"/>
@@ -5134,7 +5163,7 @@
             <a:r>
               <a:rPr lang="en-US" sz="1300" dirty="0">
                 <a:solidFill>
-                  <a:srgbClr val="ECECF4"/>
+                  <a:srgbClr val="D7E3DF"/>
                 </a:solidFill>
                 <a:latin typeface="Courier New" pitchFamily="34" charset="0"/>
                 <a:ea typeface="Courier New" pitchFamily="34" charset="-122"/>
@@ -5152,7 +5181,7 @@
             <a:r>
               <a:rPr lang="en-US" sz="1300" dirty="0">
                 <a:solidFill>
-                  <a:srgbClr val="6B6B85"/>
+                  <a:srgbClr val="6F857D"/>
                 </a:solidFill>
                 <a:latin typeface="Courier New" pitchFamily="34" charset="0"/>
                 <a:ea typeface="Courier New" pitchFamily="34" charset="-122"/>
@@ -5170,7 +5199,7 @@
             <a:r>
               <a:rPr lang="en-US" sz="1300" dirty="0">
                 <a:solidFill>
-                  <a:srgbClr val="6B6B85"/>
+                  <a:srgbClr val="6F857D"/>
                 </a:solidFill>
                 <a:latin typeface="Courier New" pitchFamily="34" charset="0"/>
                 <a:ea typeface="Courier New" pitchFamily="34" charset="-122"/>
@@ -5188,7 +5217,7 @@
             <a:r>
               <a:rPr lang="en-US" sz="1300" dirty="0">
                 <a:solidFill>
-                  <a:srgbClr val="45D0D0"/>
+                  <a:srgbClr val="25D366"/>
                 </a:solidFill>
                 <a:latin typeface="Courier New" pitchFamily="34" charset="0"/>
                 <a:ea typeface="Courier New" pitchFamily="34" charset="-122"/>
@@ -5206,7 +5235,7 @@
             <a:r>
               <a:rPr lang="en-US" sz="1300" dirty="0">
                 <a:solidFill>
-                  <a:srgbClr val="45D0D0"/>
+                  <a:srgbClr val="25D366"/>
                 </a:solidFill>
                 <a:latin typeface="Courier New" pitchFamily="34" charset="0"/>
                 <a:ea typeface="Courier New" pitchFamily="34" charset="-122"/>
@@ -5224,7 +5253,7 @@
             <a:r>
               <a:rPr lang="en-US" sz="1300" dirty="0">
                 <a:solidFill>
-                  <a:srgbClr val="ECECF4"/>
+                  <a:srgbClr val="D7E3DF"/>
                 </a:solidFill>
                 <a:latin typeface="Courier New" pitchFamily="34" charset="0"/>
                 <a:ea typeface="Courier New" pitchFamily="34" charset="-122"/>
@@ -5263,7 +5292,7 @@
             <a:r>
               <a:rPr lang="en-US" sz="1400" dirty="0">
                 <a:solidFill>
-                  <a:srgbClr val="9A9AB4"/>
+                  <a:srgbClr val="5B6B66"/>
                 </a:solidFill>
                 <a:latin typeface="Calibri" pitchFamily="34" charset="0"/>
                 <a:ea typeface="Calibri" pitchFamily="34" charset="-122"/>
@@ -5289,7 +5318,7 @@
     <p:bg>
       <p:bgPr>
         <a:solidFill>
-          <a:srgbClr val="0D0D12"/>
+          <a:srgbClr val="EEF1EC"/>
         </a:solidFill>
       </p:bgPr>
     </p:bg>
@@ -5334,7 +5363,7 @@
             <a:r>
               <a:rPr lang="en-US" sz="3800" b="1" spc="-50" kern="0" dirty="0">
                 <a:solidFill>
-                  <a:srgbClr val="ECECF4"/>
+                  <a:srgbClr val="111B21"/>
                 </a:solidFill>
                 <a:latin typeface="Calibri" pitchFamily="34" charset="0"/>
                 <a:ea typeface="Calibri" pitchFamily="34" charset="-122"/>
@@ -5363,11 +5392,11 @@
             </a:avLst>
           </a:prstGeom>
           <a:solidFill>
-            <a:srgbClr val="181823"/>
+            <a:srgbClr val="FFFFFF"/>
           </a:solidFill>
           <a:ln w="12700">
             <a:solidFill>
-              <a:srgbClr val="2A2A3A"/>
+              <a:srgbClr val="E2DDD5"/>
             </a:solidFill>
             <a:prstDash val="solid"/>
           </a:ln>
@@ -5400,7 +5429,7 @@
             <a:r>
               <a:rPr lang="en-US" sz="4600" b="1" dirty="0">
                 <a:solidFill>
-                  <a:srgbClr val="B14DFF"/>
+                  <a:srgbClr val="008069"/>
                 </a:solidFill>
                 <a:latin typeface="Calibri" pitchFamily="34" charset="0"/>
                 <a:ea typeface="Calibri" pitchFamily="34" charset="-122"/>
@@ -5439,7 +5468,7 @@
             <a:r>
               <a:rPr lang="en-US" sz="1300" dirty="0">
                 <a:solidFill>
-                  <a:srgbClr val="9A9AB4"/>
+                  <a:srgbClr val="5B6B66"/>
                 </a:solidFill>
                 <a:latin typeface="Calibri" pitchFamily="34" charset="0"/>
                 <a:ea typeface="Calibri" pitchFamily="34" charset="-122"/>
@@ -5468,11 +5497,11 @@
             </a:avLst>
           </a:prstGeom>
           <a:solidFill>
-            <a:srgbClr val="181823"/>
+            <a:srgbClr val="FFFFFF"/>
           </a:solidFill>
           <a:ln w="12700">
             <a:solidFill>
-              <a:srgbClr val="2A2A3A"/>
+              <a:srgbClr val="E2DDD5"/>
             </a:solidFill>
             <a:prstDash val="solid"/>
           </a:ln>
@@ -5505,7 +5534,7 @@
             <a:r>
               <a:rPr lang="en-US" sz="4600" b="1" dirty="0">
                 <a:solidFill>
-                  <a:srgbClr val="B14DFF"/>
+                  <a:srgbClr val="008069"/>
                 </a:solidFill>
                 <a:latin typeface="Calibri" pitchFamily="34" charset="0"/>
                 <a:ea typeface="Calibri" pitchFamily="34" charset="-122"/>
@@ -5544,7 +5573,7 @@
             <a:r>
               <a:rPr lang="en-US" sz="1300" dirty="0">
                 <a:solidFill>
-                  <a:srgbClr val="9A9AB4"/>
+                  <a:srgbClr val="5B6B66"/>
                 </a:solidFill>
                 <a:latin typeface="Calibri" pitchFamily="34" charset="0"/>
                 <a:ea typeface="Calibri" pitchFamily="34" charset="-122"/>
@@ -5573,11 +5602,11 @@
             </a:avLst>
           </a:prstGeom>
           <a:solidFill>
-            <a:srgbClr val="181823"/>
+            <a:srgbClr val="FFFFFF"/>
           </a:solidFill>
           <a:ln w="12700">
             <a:solidFill>
-              <a:srgbClr val="2A2A3A"/>
+              <a:srgbClr val="E2DDD5"/>
             </a:solidFill>
             <a:prstDash val="solid"/>
           </a:ln>
@@ -5610,7 +5639,7 @@
             <a:r>
               <a:rPr lang="en-US" sz="4600" b="1" dirty="0">
                 <a:solidFill>
-                  <a:srgbClr val="B14DFF"/>
+                  <a:srgbClr val="008069"/>
                 </a:solidFill>
                 <a:latin typeface="Calibri" pitchFamily="34" charset="0"/>
                 <a:ea typeface="Calibri" pitchFamily="34" charset="-122"/>
@@ -5649,7 +5678,7 @@
             <a:r>
               <a:rPr lang="en-US" sz="1300" dirty="0">
                 <a:solidFill>
-                  <a:srgbClr val="9A9AB4"/>
+                  <a:srgbClr val="5B6B66"/>
                 </a:solidFill>
                 <a:latin typeface="Calibri" pitchFamily="34" charset="0"/>
                 <a:ea typeface="Calibri" pitchFamily="34" charset="-122"/>
@@ -5678,11 +5707,11 @@
             </a:avLst>
           </a:prstGeom>
           <a:solidFill>
-            <a:srgbClr val="181823"/>
+            <a:srgbClr val="FFFFFF"/>
           </a:solidFill>
           <a:ln w="12700">
             <a:solidFill>
-              <a:srgbClr val="2A2A3A"/>
+              <a:srgbClr val="E2DDD5"/>
             </a:solidFill>
             <a:prstDash val="solid"/>
           </a:ln>
@@ -5715,7 +5744,7 @@
             <a:r>
               <a:rPr lang="en-US" sz="4600" b="1" dirty="0">
                 <a:solidFill>
-                  <a:srgbClr val="B14DFF"/>
+                  <a:srgbClr val="008069"/>
                 </a:solidFill>
                 <a:latin typeface="Calibri" pitchFamily="34" charset="0"/>
                 <a:ea typeface="Calibri" pitchFamily="34" charset="-122"/>
@@ -5754,7 +5783,7 @@
             <a:r>
               <a:rPr lang="en-US" sz="1300" dirty="0">
                 <a:solidFill>
-                  <a:srgbClr val="9A9AB4"/>
+                  <a:srgbClr val="5B6B66"/>
                 </a:solidFill>
                 <a:latin typeface="Calibri" pitchFamily="34" charset="0"/>
                 <a:ea typeface="Calibri" pitchFamily="34" charset="-122"/>
@@ -5793,7 +5822,7 @@
             <a:r>
               <a:rPr lang="en-US" sz="1600" dirty="0">
                 <a:solidFill>
-                  <a:srgbClr val="B14DFF"/>
+                  <a:srgbClr val="25D366"/>
                 </a:solidFill>
                 <a:latin typeface="Calibri" pitchFamily="34" charset="0"/>
                 <a:ea typeface="Calibri" pitchFamily="34" charset="-122"/>
@@ -5832,7 +5861,7 @@
             <a:r>
               <a:rPr lang="en-US" sz="1700" dirty="0">
                 <a:solidFill>
-                  <a:srgbClr val="ECECF4"/>
+                  <a:srgbClr val="111B21"/>
                 </a:solidFill>
                 <a:latin typeface="Calibri" pitchFamily="34" charset="0"/>
                 <a:ea typeface="Calibri" pitchFamily="34" charset="-122"/>
@@ -5871,7 +5900,7 @@
             <a:r>
               <a:rPr lang="en-US" sz="1600" dirty="0">
                 <a:solidFill>
-                  <a:srgbClr val="B14DFF"/>
+                  <a:srgbClr val="25D366"/>
                 </a:solidFill>
                 <a:latin typeface="Calibri" pitchFamily="34" charset="0"/>
                 <a:ea typeface="Calibri" pitchFamily="34" charset="-122"/>
@@ -5910,7 +5939,7 @@
             <a:r>
               <a:rPr lang="en-US" sz="1700" dirty="0">
                 <a:solidFill>
-                  <a:srgbClr val="ECECF4"/>
+                  <a:srgbClr val="111B21"/>
                 </a:solidFill>
                 <a:latin typeface="Calibri" pitchFamily="34" charset="0"/>
                 <a:ea typeface="Calibri" pitchFamily="34" charset="-122"/>
@@ -5949,7 +5978,7 @@
             <a:r>
               <a:rPr lang="en-US" sz="1600" dirty="0">
                 <a:solidFill>
-                  <a:srgbClr val="B14DFF"/>
+                  <a:srgbClr val="25D366"/>
                 </a:solidFill>
                 <a:latin typeface="Calibri" pitchFamily="34" charset="0"/>
                 <a:ea typeface="Calibri" pitchFamily="34" charset="-122"/>
@@ -5988,7 +6017,7 @@
             <a:r>
               <a:rPr lang="en-US" sz="1700" dirty="0">
                 <a:solidFill>
-                  <a:srgbClr val="ECECF4"/>
+                  <a:srgbClr val="111B21"/>
                 </a:solidFill>
                 <a:latin typeface="Calibri" pitchFamily="34" charset="0"/>
                 <a:ea typeface="Calibri" pitchFamily="34" charset="-122"/>
@@ -6027,7 +6056,7 @@
             <a:r>
               <a:rPr lang="en-US" sz="1600" dirty="0">
                 <a:solidFill>
-                  <a:srgbClr val="B14DFF"/>
+                  <a:srgbClr val="25D366"/>
                 </a:solidFill>
                 <a:latin typeface="Calibri" pitchFamily="34" charset="0"/>
                 <a:ea typeface="Calibri" pitchFamily="34" charset="-122"/>
@@ -6066,7 +6095,7 @@
             <a:r>
               <a:rPr lang="en-US" sz="1700" dirty="0">
                 <a:solidFill>
-                  <a:srgbClr val="ECECF4"/>
+                  <a:srgbClr val="111B21"/>
                 </a:solidFill>
                 <a:latin typeface="Calibri" pitchFamily="34" charset="0"/>
                 <a:ea typeface="Calibri" pitchFamily="34" charset="-122"/>
@@ -6092,7 +6121,7 @@
     <p:bg>
       <p:bgPr>
         <a:solidFill>
-          <a:srgbClr val="0D0D12"/>
+          <a:srgbClr val="EEF1EC"/>
         </a:solidFill>
       </p:bgPr>
     </p:bg>
@@ -6137,7 +6166,7 @@
             <a:r>
               <a:rPr lang="en-US" sz="3800" b="1" spc="-50" kern="0" dirty="0">
                 <a:solidFill>
-                  <a:srgbClr val="ECECF4"/>
+                  <a:srgbClr val="111B21"/>
                 </a:solidFill>
                 <a:latin typeface="Calibri" pitchFamily="34" charset="0"/>
                 <a:ea typeface="Calibri" pitchFamily="34" charset="-122"/>
@@ -6176,7 +6205,7 @@
             <a:r>
               <a:rPr lang="en-US" sz="1800" dirty="0">
                 <a:solidFill>
-                  <a:srgbClr val="B14DFF"/>
+                  <a:srgbClr val="25D366"/>
                 </a:solidFill>
                 <a:latin typeface="Calibri" pitchFamily="34" charset="0"/>
                 <a:ea typeface="Calibri" pitchFamily="34" charset="-122"/>
@@ -6215,7 +6244,7 @@
             <a:r>
               <a:rPr lang="en-US" sz="1800" b="1" dirty="0">
                 <a:solidFill>
-                  <a:srgbClr val="ECECF4"/>
+                  <a:srgbClr val="111B21"/>
                 </a:solidFill>
                 <a:latin typeface="Calibri" pitchFamily="34" charset="0"/>
                 <a:ea typeface="Calibri" pitchFamily="34" charset="-122"/>
@@ -6229,7 +6258,7 @@
             <a:r>
               <a:rPr lang="en-US" sz="1800" dirty="0">
                 <a:solidFill>
-                  <a:srgbClr val="9A9AB4"/>
+                  <a:srgbClr val="5B6B66"/>
                 </a:solidFill>
                 <a:latin typeface="Calibri" pitchFamily="34" charset="0"/>
                 <a:ea typeface="Calibri" pitchFamily="34" charset="-122"/>
@@ -6268,7 +6297,7 @@
             <a:r>
               <a:rPr lang="en-US" sz="1800" dirty="0">
                 <a:solidFill>
-                  <a:srgbClr val="B14DFF"/>
+                  <a:srgbClr val="25D366"/>
                 </a:solidFill>
                 <a:latin typeface="Calibri" pitchFamily="34" charset="0"/>
                 <a:ea typeface="Calibri" pitchFamily="34" charset="-122"/>
@@ -6307,7 +6336,7 @@
             <a:r>
               <a:rPr lang="en-US" sz="1800" b="1" dirty="0">
                 <a:solidFill>
-                  <a:srgbClr val="ECECF4"/>
+                  <a:srgbClr val="111B21"/>
                 </a:solidFill>
                 <a:latin typeface="Calibri" pitchFamily="34" charset="0"/>
                 <a:ea typeface="Calibri" pitchFamily="34" charset="-122"/>
@@ -6321,7 +6350,7 @@
             <a:r>
               <a:rPr lang="en-US" sz="1800" dirty="0">
                 <a:solidFill>
-                  <a:srgbClr val="9A9AB4"/>
+                  <a:srgbClr val="5B6B66"/>
                 </a:solidFill>
                 <a:latin typeface="Calibri" pitchFamily="34" charset="0"/>
                 <a:ea typeface="Calibri" pitchFamily="34" charset="-122"/>
@@ -6360,7 +6389,7 @@
             <a:r>
               <a:rPr lang="en-US" sz="1800" dirty="0">
                 <a:solidFill>
-                  <a:srgbClr val="B14DFF"/>
+                  <a:srgbClr val="25D366"/>
                 </a:solidFill>
                 <a:latin typeface="Calibri" pitchFamily="34" charset="0"/>
                 <a:ea typeface="Calibri" pitchFamily="34" charset="-122"/>
@@ -6399,7 +6428,7 @@
             <a:r>
               <a:rPr lang="en-US" sz="1800" b="1" dirty="0">
                 <a:solidFill>
-                  <a:srgbClr val="ECECF4"/>
+                  <a:srgbClr val="111B21"/>
                 </a:solidFill>
                 <a:latin typeface="Calibri" pitchFamily="34" charset="0"/>
                 <a:ea typeface="Calibri" pitchFamily="34" charset="-122"/>
@@ -6413,7 +6442,7 @@
             <a:r>
               <a:rPr lang="en-US" sz="1800" dirty="0">
                 <a:solidFill>
-                  <a:srgbClr val="9A9AB4"/>
+                  <a:srgbClr val="5B6B66"/>
                 </a:solidFill>
                 <a:latin typeface="Calibri" pitchFamily="34" charset="0"/>
                 <a:ea typeface="Calibri" pitchFamily="34" charset="-122"/>
@@ -6452,7 +6481,7 @@
             <a:r>
               <a:rPr lang="en-US" sz="1800" dirty="0">
                 <a:solidFill>
-                  <a:srgbClr val="B14DFF"/>
+                  <a:srgbClr val="25D366"/>
                 </a:solidFill>
                 <a:latin typeface="Calibri" pitchFamily="34" charset="0"/>
                 <a:ea typeface="Calibri" pitchFamily="34" charset="-122"/>
@@ -6491,7 +6520,7 @@
             <a:r>
               <a:rPr lang="en-US" sz="1800" b="1" dirty="0">
                 <a:solidFill>
-                  <a:srgbClr val="ECECF4"/>
+                  <a:srgbClr val="111B21"/>
                 </a:solidFill>
                 <a:latin typeface="Calibri" pitchFamily="34" charset="0"/>
                 <a:ea typeface="Calibri" pitchFamily="34" charset="-122"/>
@@ -6505,7 +6534,7 @@
             <a:r>
               <a:rPr lang="en-US" sz="1800" dirty="0">
                 <a:solidFill>
-                  <a:srgbClr val="9A9AB4"/>
+                  <a:srgbClr val="5B6B66"/>
                 </a:solidFill>
                 <a:latin typeface="Calibri" pitchFamily="34" charset="0"/>
                 <a:ea typeface="Calibri" pitchFamily="34" charset="-122"/>
@@ -6544,7 +6573,7 @@
             <a:r>
               <a:rPr lang="en-US" sz="1400" dirty="0">
                 <a:solidFill>
-                  <a:srgbClr val="9A9AB4"/>
+                  <a:srgbClr val="5B6B66"/>
                 </a:solidFill>
                 <a:latin typeface="Calibri" pitchFamily="34" charset="0"/>
                 <a:ea typeface="Calibri" pitchFamily="34" charset="-122"/>

</xml_diff>